<commit_message>
docs: join the agentic coding loop arrows to the return bar
Co-authored-by: 69515164-rgb <69515164-rgb@users.noreply.github.com>
</commit_message>
<xml_diff>
--- a/docs/agentic-coding-flow.pptx
+++ b/docs/agentic-coding-flow.pptx
@@ -4204,8 +4204,8 @@
         </p:nvSpPr>
         <p:spPr>
           <a:xfrm>
-            <a:off x="10233507" y="3758183"/>
-            <a:ext cx="310896" cy="420624"/>
+            <a:off x="10233507" y="3703320"/>
+            <a:ext cx="310896" cy="630935"/>
           </a:xfrm>
           <a:prstGeom prst="downArrow">
             <a:avLst/>
@@ -4247,8 +4247,8 @@
         </p:nvSpPr>
         <p:spPr>
           <a:xfrm>
-            <a:off x="1647291" y="3758183"/>
-            <a:ext cx="310896" cy="420624"/>
+            <a:off x="1647291" y="3703320"/>
+            <a:ext cx="310896" cy="630935"/>
           </a:xfrm>
           <a:prstGeom prst="upArrow">
             <a:avLst/>

</xml_diff>